<commit_message>
fix: generator self-regulation cap 1B -> 1T (item 56)
</commit_message>
<xml_diff>
--- a/data/generator-self-regulation/deck.pptx
+++ b/data/generator-self-regulation/deck.pptx
@@ -3656,7 +3656,7 @@
                 </a:solidFill>
                 <a:latin typeface="Calibri"/>
               </a:rPr>
-              <a:t>1. The One-Billion Hard Cap  [JAH-GSR-000001]</a:t>
+              <a:t>1. The One-Trillion Hard Cap  [JAH-GSR-000001]</a:t>
             </a:r>
           </a:p>
           <a:p>
@@ -3672,7 +3672,7 @@
                 </a:solidFill>
                 <a:latin typeface="Calibri"/>
               </a:rPr>
-              <a:t>   No boundless generator may ever produce more than 1,000,000,000 records. The cap is enforced inside the generation wrapper itself — not in calling code — so no caller can forget or bypass it. When th…</a:t>
+              <a:t>   No boundless generator may ever produce more than 1,000,000,000,000 records. The cap is enforced inside the generation wrapper itself — not in calling code — so no caller can forget or bypass it. When th…</a:t>
             </a:r>
           </a:p>
           <a:p>

</xml_diff>